<commit_message>
docs: add Le Duy Khanh to members, fix duplicate running system section
Co-Authored-By: Claude Opus 4.6 (1M context) <noreply@anthropic.com>
</commit_message>
<xml_diff>
--- a/slides/W4_presentation.pptx
+++ b/slides/W4_presentation.pptx
@@ -3352,7 +3352,7 @@
               </a:defRPr>
             </a:pPr>
             <a:r>
-              <a:t>Le Hoang Trung Kien  •  Tran Dinh Bao Long  •  Nguyen Duc Chinh</a:t>
+              <a:t>Le Hoang Trung Kien  •  Tran Dinh Bao Long  •  Nguyen Duc Chinh  •  Nguyen Huu Dinh</a:t>
             </a:r>
           </a:p>
           <a:p>
@@ -3368,7 +3368,7 @@
               </a:defRPr>
             </a:pPr>
             <a:r>
-              <a:t>Nguyen Huu Dinh  •  Truong Thi My Quyen  •  Tran Van Duc  •  Hoang Trong Tan</a:t>
+              <a:t>Truong Thi My Quyen  •  Tran Van Duc  •  Hoang Trong Tan  •  Le Duy Khanh</a:t>
             </a:r>
           </a:p>
           <a:p>

</xml_diff>

<commit_message>
docs: fix image overflow in PPTX - constrain to slide bounds
Co-Authored-By: Claude Opus 4.6 (1M context) <noreply@anthropic.com>
</commit_message>
<xml_diff>
--- a/slides/W4_presentation.pptx
+++ b/slides/W4_presentation.pptx
@@ -3570,7 +3570,7 @@
         <p:spPr>
           <a:xfrm>
             <a:off x="365760" y="1828800"/>
-            <a:ext cx="5669280" cy="6481286"/>
+            <a:ext cx="3999198" cy="4572000"/>
           </a:xfrm>
           <a:prstGeom prst="rect">
             <a:avLst/>
@@ -3594,7 +3594,7 @@
         <p:spPr>
           <a:xfrm>
             <a:off x="6217920" y="1828800"/>
-            <a:ext cx="5669280" cy="9734618"/>
+            <a:ext cx="2662656" cy="4572000"/>
           </a:xfrm>
           <a:prstGeom prst="rect">
             <a:avLst/>
@@ -3753,7 +3753,7 @@
         <p:spPr>
           <a:xfrm>
             <a:off x="365760" y="1828800"/>
-            <a:ext cx="5669280" cy="6998018"/>
+            <a:ext cx="3703898" cy="4572000"/>
           </a:xfrm>
           <a:prstGeom prst="rect">
             <a:avLst/>
@@ -3777,7 +3777,7 @@
         <p:spPr>
           <a:xfrm>
             <a:off x="6217920" y="1828800"/>
-            <a:ext cx="5669280" cy="10182027"/>
+            <a:ext cx="2545657" cy="4572000"/>
           </a:xfrm>
           <a:prstGeom prst="rect">
             <a:avLst/>
@@ -3936,7 +3936,7 @@
         <p:spPr>
           <a:xfrm>
             <a:off x="1371600" y="1828800"/>
-            <a:ext cx="9418320" cy="32767274"/>
+            <a:ext cx="1314133" cy="4572000"/>
           </a:xfrm>
           <a:prstGeom prst="rect">
             <a:avLst/>
@@ -4095,7 +4095,7 @@
         <p:spPr>
           <a:xfrm>
             <a:off x="1097280" y="1828800"/>
-            <a:ext cx="9875520" cy="11865587"/>
+            <a:ext cx="3805195" cy="4572000"/>
           </a:xfrm>
           <a:prstGeom prst="rect">
             <a:avLst/>
@@ -6516,7 +6516,7 @@
         <p:spPr>
           <a:xfrm>
             <a:off x="274320" y="1463040"/>
-            <a:ext cx="11612880" cy="5960892"/>
+            <a:ext cx="9797777" cy="5029200"/>
           </a:xfrm>
           <a:prstGeom prst="rect">
             <a:avLst/>
@@ -7440,7 +7440,7 @@
         <p:spPr>
           <a:xfrm>
             <a:off x="274320" y="1463040"/>
-            <a:ext cx="11612880" cy="5073135"/>
+            <a:ext cx="11512308" cy="5029200"/>
           </a:xfrm>
           <a:prstGeom prst="rect">
             <a:avLst/>
@@ -7560,7 +7560,7 @@
         <p:spPr>
           <a:xfrm>
             <a:off x="274320" y="1463040"/>
-            <a:ext cx="11612880" cy="6689378"/>
+            <a:ext cx="8730781" cy="5029200"/>
           </a:xfrm>
           <a:prstGeom prst="rect">
             <a:avLst/>
@@ -7901,7 +7901,7 @@
         <p:spPr>
           <a:xfrm>
             <a:off x="365760" y="1828800"/>
-            <a:ext cx="5669280" cy="6504908"/>
+            <a:ext cx="3984675" cy="4572000"/>
           </a:xfrm>
           <a:prstGeom prst="rect">
             <a:avLst/>
@@ -7925,7 +7925,7 @@
         <p:spPr>
           <a:xfrm>
             <a:off x="6217920" y="1828800"/>
-            <a:ext cx="5669280" cy="7999536"/>
+            <a:ext cx="3240181" cy="4572000"/>
           </a:xfrm>
           <a:prstGeom prst="rect">
             <a:avLst/>

</xml_diff>

<commit_message>
docs: auto-crop portrait screenshots to landscape for PPTX slides
Co-Authored-By: Claude Opus 4.6 (1M context) <noreply@anthropic.com>
</commit_message>
<xml_diff>
--- a/slides/W4_presentation.pptx
+++ b/slides/W4_presentation.pptx
@@ -3570,7 +3570,7 @@
         <p:spPr>
           <a:xfrm>
             <a:off x="365760" y="1828800"/>
-            <a:ext cx="3999198" cy="4572000"/>
+            <a:ext cx="5669280" cy="3188970"/>
           </a:xfrm>
           <a:prstGeom prst="rect">
             <a:avLst/>
@@ -3594,7 +3594,7 @@
         <p:spPr>
           <a:xfrm>
             <a:off x="6217920" y="1828800"/>
-            <a:ext cx="2662656" cy="4572000"/>
+            <a:ext cx="5669280" cy="3187709"/>
           </a:xfrm>
           <a:prstGeom prst="rect">
             <a:avLst/>
@@ -3753,7 +3753,7 @@
         <p:spPr>
           <a:xfrm>
             <a:off x="365760" y="1828800"/>
-            <a:ext cx="3703898" cy="4572000"/>
+            <a:ext cx="5669280" cy="3188970"/>
           </a:xfrm>
           <a:prstGeom prst="rect">
             <a:avLst/>
@@ -3777,7 +3777,7 @@
         <p:spPr>
           <a:xfrm>
             <a:off x="6217920" y="1828800"/>
-            <a:ext cx="2545657" cy="4572000"/>
+            <a:ext cx="5669280" cy="3186135"/>
           </a:xfrm>
           <a:prstGeom prst="rect">
             <a:avLst/>
@@ -3936,7 +3936,7 @@
         <p:spPr>
           <a:xfrm>
             <a:off x="1371600" y="1828800"/>
-            <a:ext cx="1314133" cy="4572000"/>
+            <a:ext cx="8136721" cy="4572000"/>
           </a:xfrm>
           <a:prstGeom prst="rect">
             <a:avLst/>
@@ -4095,7 +4095,7 @@
         <p:spPr>
           <a:xfrm>
             <a:off x="1097280" y="1828800"/>
-            <a:ext cx="3805195" cy="4572000"/>
+            <a:ext cx="8133477" cy="4572000"/>
           </a:xfrm>
           <a:prstGeom prst="rect">
             <a:avLst/>
@@ -7901,7 +7901,7 @@
         <p:spPr>
           <a:xfrm>
             <a:off x="365760" y="1828800"/>
-            <a:ext cx="3984675" cy="4572000"/>
+            <a:ext cx="5669280" cy="3188970"/>
           </a:xfrm>
           <a:prstGeom prst="rect">
             <a:avLst/>
@@ -7925,7 +7925,7 @@
         <p:spPr>
           <a:xfrm>
             <a:off x="6217920" y="1828800"/>
-            <a:ext cx="3240181" cy="4572000"/>
+            <a:ext cx="5669280" cy="3187709"/>
           </a:xfrm>
           <a:prstGeom prst="rect">
             <a:avLst/>

</xml_diff>